<commit_message>
AutomaTivio: "Data base:" sob a tabela de rentabilidade em todos os fundos
Co-Authored-By: Claude Opus 5.5 <noreply@anthropic.com>
</commit_message>
<xml_diff>
--- a/AutomaTivio/saida/2026-08/pptx/Tivio BVP - Relatório de Gestão - Agosto 2026.pptx
+++ b/AutomaTivio/saida/2026-08/pptx/Tivio BVP - Relatório de Gestão - Agosto 2026.pptx
@@ -4593,13 +4593,22 @@
               </a:lnSpc>
             </a:pPr>
             <a:r>
+              <a:rPr sz="744" b="1" i="0">
+                <a:solidFill>
+                  <a:srgbClr val="444444"/>
+                </a:solidFill>
+                <a:latin typeface="Versos"/>
+              </a:rPr>
+              <a:t>Data base:</a:t>
+            </a:r>
+            <a:r>
               <a:rPr sz="744" b="0" i="0">
                 <a:solidFill>
                   <a:srgbClr val="444444"/>
                 </a:solidFill>
                 <a:latin typeface="Versos"/>
               </a:rPr>
-              <a:t>31/08/2026</a:t>
+              <a:t> 31/08/2026</a:t>
             </a:r>
           </a:p>
         </p:txBody>
@@ -8257,7 +8266,7 @@
         </p:nvSpPr>
         <p:spPr>
           <a:xfrm>
-            <a:off x="604800" y="2892881"/>
+            <a:off x="604800" y="2884140"/>
             <a:ext cx="1776902" cy="151200"/>
           </a:xfrm>
           <a:prstGeom prst="rect">
@@ -8294,7 +8303,7 @@
         </p:nvSpPr>
         <p:spPr>
           <a:xfrm>
-            <a:off x="2404080" y="2892881"/>
+            <a:off x="2404080" y="2884140"/>
             <a:ext cx="833414" cy="151200"/>
           </a:xfrm>
           <a:prstGeom prst="rect">
@@ -8331,7 +8340,7 @@
         </p:nvSpPr>
         <p:spPr>
           <a:xfrm>
-            <a:off x="3296160" y="2892881"/>
+            <a:off x="3296160" y="2884140"/>
             <a:ext cx="503193" cy="151200"/>
           </a:xfrm>
           <a:prstGeom prst="rect">
@@ -8368,7 +8377,7 @@
         </p:nvSpPr>
         <p:spPr>
           <a:xfrm>
-            <a:off x="3870720" y="2892881"/>
+            <a:off x="3870720" y="2884140"/>
             <a:ext cx="723340" cy="151200"/>
           </a:xfrm>
           <a:prstGeom prst="rect">
@@ -8405,7 +8414,7 @@
         </p:nvSpPr>
         <p:spPr>
           <a:xfrm>
-            <a:off x="4656960" y="2892881"/>
+            <a:off x="4656960" y="2884140"/>
             <a:ext cx="959212" cy="151200"/>
           </a:xfrm>
           <a:prstGeom prst="rect">
@@ -8442,7 +8451,7 @@
         </p:nvSpPr>
         <p:spPr>
           <a:xfrm>
-            <a:off x="5670000" y="2892881"/>
+            <a:off x="5670000" y="2884140"/>
             <a:ext cx="644716" cy="151200"/>
           </a:xfrm>
           <a:prstGeom prst="rect">
@@ -8479,7 +8488,7 @@
         </p:nvSpPr>
         <p:spPr>
           <a:xfrm>
-            <a:off x="6380640" y="2892881"/>
+            <a:off x="6380640" y="2884140"/>
             <a:ext cx="644716" cy="151200"/>
           </a:xfrm>
           <a:prstGeom prst="rect">
@@ -8516,7 +8525,7 @@
         </p:nvSpPr>
         <p:spPr>
           <a:xfrm>
-            <a:off x="604800" y="3187721"/>
+            <a:off x="604800" y="3161379"/>
             <a:ext cx="1776902" cy="151200"/>
           </a:xfrm>
           <a:prstGeom prst="rect">
@@ -8553,7 +8562,7 @@
         </p:nvSpPr>
         <p:spPr>
           <a:xfrm>
-            <a:off x="2404080" y="3187721"/>
+            <a:off x="2404080" y="3161379"/>
             <a:ext cx="833414" cy="151200"/>
           </a:xfrm>
           <a:prstGeom prst="rect">
@@ -8590,7 +8599,7 @@
         </p:nvSpPr>
         <p:spPr>
           <a:xfrm>
-            <a:off x="3296160" y="3187721"/>
+            <a:off x="3296160" y="3161379"/>
             <a:ext cx="503193" cy="151200"/>
           </a:xfrm>
           <a:prstGeom prst="rect">
@@ -8627,7 +8636,7 @@
         </p:nvSpPr>
         <p:spPr>
           <a:xfrm>
-            <a:off x="3870720" y="3187721"/>
+            <a:off x="3870720" y="3161379"/>
             <a:ext cx="723340" cy="151200"/>
           </a:xfrm>
           <a:prstGeom prst="rect">
@@ -8664,7 +8673,7 @@
         </p:nvSpPr>
         <p:spPr>
           <a:xfrm>
-            <a:off x="4656960" y="3187721"/>
+            <a:off x="4656960" y="3161379"/>
             <a:ext cx="959212" cy="151200"/>
           </a:xfrm>
           <a:prstGeom prst="rect">
@@ -8701,7 +8710,7 @@
         </p:nvSpPr>
         <p:spPr>
           <a:xfrm>
-            <a:off x="5670000" y="3187721"/>
+            <a:off x="5670000" y="3161379"/>
             <a:ext cx="644716" cy="151200"/>
           </a:xfrm>
           <a:prstGeom prst="rect">
@@ -8738,7 +8747,7 @@
         </p:nvSpPr>
         <p:spPr>
           <a:xfrm>
-            <a:off x="6380640" y="3187721"/>
+            <a:off x="6380640" y="3161379"/>
             <a:ext cx="644716" cy="151200"/>
           </a:xfrm>
           <a:prstGeom prst="rect">
@@ -8775,7 +8784,7 @@
         </p:nvSpPr>
         <p:spPr>
           <a:xfrm>
-            <a:off x="604800" y="3482561"/>
+            <a:off x="604800" y="3438618"/>
             <a:ext cx="1776902" cy="151200"/>
           </a:xfrm>
           <a:prstGeom prst="rect">
@@ -8812,7 +8821,7 @@
         </p:nvSpPr>
         <p:spPr>
           <a:xfrm>
-            <a:off x="2404080" y="3482561"/>
+            <a:off x="2404080" y="3438618"/>
             <a:ext cx="833414" cy="151200"/>
           </a:xfrm>
           <a:prstGeom prst="rect">
@@ -8849,7 +8858,7 @@
         </p:nvSpPr>
         <p:spPr>
           <a:xfrm>
-            <a:off x="3296160" y="3482561"/>
+            <a:off x="3296160" y="3438618"/>
             <a:ext cx="503193" cy="151200"/>
           </a:xfrm>
           <a:prstGeom prst="rect">
@@ -8886,7 +8895,7 @@
         </p:nvSpPr>
         <p:spPr>
           <a:xfrm>
-            <a:off x="3870720" y="3482561"/>
+            <a:off x="3870720" y="3438618"/>
             <a:ext cx="723340" cy="151200"/>
           </a:xfrm>
           <a:prstGeom prst="rect">
@@ -8923,7 +8932,7 @@
         </p:nvSpPr>
         <p:spPr>
           <a:xfrm>
-            <a:off x="4656960" y="3482561"/>
+            <a:off x="4656960" y="3438618"/>
             <a:ext cx="959212" cy="151200"/>
           </a:xfrm>
           <a:prstGeom prst="rect">
@@ -8960,7 +8969,7 @@
         </p:nvSpPr>
         <p:spPr>
           <a:xfrm>
-            <a:off x="5670000" y="3482561"/>
+            <a:off x="5670000" y="3438618"/>
             <a:ext cx="644716" cy="151200"/>
           </a:xfrm>
           <a:prstGeom prst="rect">
@@ -8997,7 +9006,7 @@
         </p:nvSpPr>
         <p:spPr>
           <a:xfrm>
-            <a:off x="6380640" y="3482561"/>
+            <a:off x="6380640" y="3438618"/>
             <a:ext cx="644716" cy="151200"/>
           </a:xfrm>
           <a:prstGeom prst="rect">
@@ -9034,7 +9043,7 @@
         </p:nvSpPr>
         <p:spPr>
           <a:xfrm>
-            <a:off x="604800" y="3777401"/>
+            <a:off x="604800" y="3715858"/>
             <a:ext cx="1776902" cy="151200"/>
           </a:xfrm>
           <a:prstGeom prst="rect">
@@ -9071,7 +9080,7 @@
         </p:nvSpPr>
         <p:spPr>
           <a:xfrm>
-            <a:off x="2404080" y="3777401"/>
+            <a:off x="2404080" y="3715858"/>
             <a:ext cx="833414" cy="151200"/>
           </a:xfrm>
           <a:prstGeom prst="rect">
@@ -9108,7 +9117,7 @@
         </p:nvSpPr>
         <p:spPr>
           <a:xfrm>
-            <a:off x="3296160" y="3777401"/>
+            <a:off x="3296160" y="3715858"/>
             <a:ext cx="503193" cy="151200"/>
           </a:xfrm>
           <a:prstGeom prst="rect">
@@ -9145,7 +9154,7 @@
         </p:nvSpPr>
         <p:spPr>
           <a:xfrm>
-            <a:off x="3870720" y="3777401"/>
+            <a:off x="3870720" y="3715858"/>
             <a:ext cx="723340" cy="151200"/>
           </a:xfrm>
           <a:prstGeom prst="rect">
@@ -9182,7 +9191,7 @@
         </p:nvSpPr>
         <p:spPr>
           <a:xfrm>
-            <a:off x="4656960" y="3777401"/>
+            <a:off x="4656960" y="3715858"/>
             <a:ext cx="959212" cy="151200"/>
           </a:xfrm>
           <a:prstGeom prst="rect">
@@ -9219,7 +9228,7 @@
         </p:nvSpPr>
         <p:spPr>
           <a:xfrm>
-            <a:off x="5670000" y="3777401"/>
+            <a:off x="5670000" y="3715858"/>
             <a:ext cx="644716" cy="151200"/>
           </a:xfrm>
           <a:prstGeom prst="rect">
@@ -9256,7 +9265,7 @@
         </p:nvSpPr>
         <p:spPr>
           <a:xfrm>
-            <a:off x="6380640" y="3777401"/>
+            <a:off x="6380640" y="3715858"/>
             <a:ext cx="644716" cy="151200"/>
           </a:xfrm>
           <a:prstGeom prst="rect">
@@ -9293,7 +9302,7 @@
         </p:nvSpPr>
         <p:spPr>
           <a:xfrm>
-            <a:off x="604800" y="4072241"/>
+            <a:off x="604800" y="3993097"/>
             <a:ext cx="1776902" cy="151200"/>
           </a:xfrm>
           <a:prstGeom prst="rect">
@@ -9330,7 +9339,7 @@
         </p:nvSpPr>
         <p:spPr>
           <a:xfrm>
-            <a:off x="2404080" y="4072241"/>
+            <a:off x="2404080" y="3993097"/>
             <a:ext cx="833414" cy="151200"/>
           </a:xfrm>
           <a:prstGeom prst="rect">
@@ -9367,7 +9376,7 @@
         </p:nvSpPr>
         <p:spPr>
           <a:xfrm>
-            <a:off x="3296160" y="4072241"/>
+            <a:off x="3296160" y="3993097"/>
             <a:ext cx="503193" cy="151200"/>
           </a:xfrm>
           <a:prstGeom prst="rect">
@@ -9404,7 +9413,7 @@
         </p:nvSpPr>
         <p:spPr>
           <a:xfrm>
-            <a:off x="3870720" y="4072241"/>
+            <a:off x="3870720" y="3993097"/>
             <a:ext cx="723340" cy="151200"/>
           </a:xfrm>
           <a:prstGeom prst="rect">
@@ -9441,7 +9450,7 @@
         </p:nvSpPr>
         <p:spPr>
           <a:xfrm>
-            <a:off x="4656960" y="4072241"/>
+            <a:off x="4656960" y="3993097"/>
             <a:ext cx="959212" cy="151200"/>
           </a:xfrm>
           <a:prstGeom prst="rect">
@@ -9478,7 +9487,7 @@
         </p:nvSpPr>
         <p:spPr>
           <a:xfrm>
-            <a:off x="5670000" y="4072241"/>
+            <a:off x="5670000" y="3993097"/>
             <a:ext cx="644716" cy="151200"/>
           </a:xfrm>
           <a:prstGeom prst="rect">
@@ -9515,7 +9524,7 @@
         </p:nvSpPr>
         <p:spPr>
           <a:xfrm>
-            <a:off x="6380640" y="4072241"/>
+            <a:off x="6380640" y="3993097"/>
             <a:ext cx="644716" cy="151200"/>
           </a:xfrm>
           <a:prstGeom prst="rect">
@@ -9552,7 +9561,7 @@
         </p:nvSpPr>
         <p:spPr>
           <a:xfrm>
-            <a:off x="604800" y="4367081"/>
+            <a:off x="604800" y="4270336"/>
             <a:ext cx="1776902" cy="151200"/>
           </a:xfrm>
           <a:prstGeom prst="rect">
@@ -9589,7 +9598,7 @@
         </p:nvSpPr>
         <p:spPr>
           <a:xfrm>
-            <a:off x="2404080" y="4367081"/>
+            <a:off x="2404080" y="4270336"/>
             <a:ext cx="833414" cy="151200"/>
           </a:xfrm>
           <a:prstGeom prst="rect">
@@ -9626,7 +9635,7 @@
         </p:nvSpPr>
         <p:spPr>
           <a:xfrm>
-            <a:off x="3296160" y="4367081"/>
+            <a:off x="3296160" y="4270336"/>
             <a:ext cx="503193" cy="151200"/>
           </a:xfrm>
           <a:prstGeom prst="rect">
@@ -9663,7 +9672,7 @@
         </p:nvSpPr>
         <p:spPr>
           <a:xfrm>
-            <a:off x="3870720" y="4367081"/>
+            <a:off x="3870720" y="4270336"/>
             <a:ext cx="723340" cy="151200"/>
           </a:xfrm>
           <a:prstGeom prst="rect">
@@ -9700,7 +9709,7 @@
         </p:nvSpPr>
         <p:spPr>
           <a:xfrm>
-            <a:off x="4656960" y="4367081"/>
+            <a:off x="4656960" y="4270336"/>
             <a:ext cx="959212" cy="151200"/>
           </a:xfrm>
           <a:prstGeom prst="rect">
@@ -9737,7 +9746,7 @@
         </p:nvSpPr>
         <p:spPr>
           <a:xfrm>
-            <a:off x="5670000" y="4367081"/>
+            <a:off x="5670000" y="4270336"/>
             <a:ext cx="644716" cy="151200"/>
           </a:xfrm>
           <a:prstGeom prst="rect">
@@ -9774,7 +9783,7 @@
         </p:nvSpPr>
         <p:spPr>
           <a:xfrm>
-            <a:off x="6380640" y="4367081"/>
+            <a:off x="6380640" y="4270336"/>
             <a:ext cx="644716" cy="151200"/>
           </a:xfrm>
           <a:prstGeom prst="rect">
@@ -9811,7 +9820,7 @@
         </p:nvSpPr>
         <p:spPr>
           <a:xfrm>
-            <a:off x="604800" y="4603567"/>
+            <a:off x="604800" y="4505878"/>
             <a:ext cx="1708560" cy="298974"/>
           </a:xfrm>
           <a:prstGeom prst="rect">
@@ -9848,7 +9857,7 @@
         </p:nvSpPr>
         <p:spPr>
           <a:xfrm>
-            <a:off x="2404080" y="4677395"/>
+            <a:off x="2404080" y="4579706"/>
             <a:ext cx="833414" cy="151200"/>
           </a:xfrm>
           <a:prstGeom prst="rect">
@@ -9885,7 +9894,7 @@
         </p:nvSpPr>
         <p:spPr>
           <a:xfrm>
-            <a:off x="3296160" y="4677395"/>
+            <a:off x="3296160" y="4579706"/>
             <a:ext cx="503193" cy="151200"/>
           </a:xfrm>
           <a:prstGeom prst="rect">
@@ -9922,7 +9931,7 @@
         </p:nvSpPr>
         <p:spPr>
           <a:xfrm>
-            <a:off x="3870720" y="4677395"/>
+            <a:off x="3870720" y="4579706"/>
             <a:ext cx="723340" cy="151200"/>
           </a:xfrm>
           <a:prstGeom prst="rect">
@@ -9959,7 +9968,7 @@
         </p:nvSpPr>
         <p:spPr>
           <a:xfrm>
-            <a:off x="4656960" y="4677395"/>
+            <a:off x="4656960" y="4579706"/>
             <a:ext cx="959212" cy="151200"/>
           </a:xfrm>
           <a:prstGeom prst="rect">
@@ -9996,7 +10005,7 @@
         </p:nvSpPr>
         <p:spPr>
           <a:xfrm>
-            <a:off x="5670000" y="4677395"/>
+            <a:off x="5670000" y="4579706"/>
             <a:ext cx="644716" cy="151200"/>
           </a:xfrm>
           <a:prstGeom prst="rect">
@@ -10033,7 +10042,7 @@
         </p:nvSpPr>
         <p:spPr>
           <a:xfrm>
-            <a:off x="6380640" y="4677395"/>
+            <a:off x="6380640" y="4579706"/>
             <a:ext cx="644716" cy="151200"/>
           </a:xfrm>
           <a:prstGeom prst="rect">
@@ -10070,7 +10079,7 @@
         </p:nvSpPr>
         <p:spPr>
           <a:xfrm>
-            <a:off x="604800" y="4987710"/>
+            <a:off x="604800" y="4889193"/>
             <a:ext cx="1776902" cy="151200"/>
           </a:xfrm>
           <a:prstGeom prst="rect">
@@ -10107,7 +10116,7 @@
         </p:nvSpPr>
         <p:spPr>
           <a:xfrm>
-            <a:off x="2404080" y="4987710"/>
+            <a:off x="2404080" y="4889193"/>
             <a:ext cx="833414" cy="151200"/>
           </a:xfrm>
           <a:prstGeom prst="rect">
@@ -10144,7 +10153,7 @@
         </p:nvSpPr>
         <p:spPr>
           <a:xfrm>
-            <a:off x="3296160" y="4987710"/>
+            <a:off x="3296160" y="4889193"/>
             <a:ext cx="503193" cy="151200"/>
           </a:xfrm>
           <a:prstGeom prst="rect">
@@ -10181,7 +10190,7 @@
         </p:nvSpPr>
         <p:spPr>
           <a:xfrm>
-            <a:off x="3870720" y="4987710"/>
+            <a:off x="3870720" y="4889193"/>
             <a:ext cx="723340" cy="151200"/>
           </a:xfrm>
           <a:prstGeom prst="rect">
@@ -10218,7 +10227,7 @@
         </p:nvSpPr>
         <p:spPr>
           <a:xfrm>
-            <a:off x="4656960" y="4987710"/>
+            <a:off x="4656960" y="4889193"/>
             <a:ext cx="959212" cy="151200"/>
           </a:xfrm>
           <a:prstGeom prst="rect">
@@ -10255,7 +10264,7 @@
         </p:nvSpPr>
         <p:spPr>
           <a:xfrm>
-            <a:off x="5670000" y="4987710"/>
+            <a:off x="5670000" y="4889193"/>
             <a:ext cx="644716" cy="151200"/>
           </a:xfrm>
           <a:prstGeom prst="rect">
@@ -10292,7 +10301,7 @@
         </p:nvSpPr>
         <p:spPr>
           <a:xfrm>
-            <a:off x="6380640" y="4987710"/>
+            <a:off x="6380640" y="4889193"/>
             <a:ext cx="644716" cy="151200"/>
           </a:xfrm>
           <a:prstGeom prst="rect">
@@ -10329,7 +10338,7 @@
         </p:nvSpPr>
         <p:spPr>
           <a:xfrm>
-            <a:off x="604800" y="5282550"/>
+            <a:off x="604800" y="5166433"/>
             <a:ext cx="1776902" cy="151200"/>
           </a:xfrm>
           <a:prstGeom prst="rect">
@@ -10366,7 +10375,7 @@
         </p:nvSpPr>
         <p:spPr>
           <a:xfrm>
-            <a:off x="2404080" y="5282550"/>
+            <a:off x="2404080" y="5166433"/>
             <a:ext cx="833414" cy="151200"/>
           </a:xfrm>
           <a:prstGeom prst="rect">
@@ -10403,7 +10412,7 @@
         </p:nvSpPr>
         <p:spPr>
           <a:xfrm>
-            <a:off x="3296160" y="5282550"/>
+            <a:off x="3296160" y="5166433"/>
             <a:ext cx="503193" cy="151200"/>
           </a:xfrm>
           <a:prstGeom prst="rect">
@@ -10440,7 +10449,7 @@
         </p:nvSpPr>
         <p:spPr>
           <a:xfrm>
-            <a:off x="3870720" y="5282550"/>
+            <a:off x="3870720" y="5166433"/>
             <a:ext cx="723340" cy="151200"/>
           </a:xfrm>
           <a:prstGeom prst="rect">
@@ -10477,7 +10486,7 @@
         </p:nvSpPr>
         <p:spPr>
           <a:xfrm>
-            <a:off x="4656960" y="5282550"/>
+            <a:off x="4656960" y="5166433"/>
             <a:ext cx="959212" cy="151200"/>
           </a:xfrm>
           <a:prstGeom prst="rect">
@@ -10514,7 +10523,7 @@
         </p:nvSpPr>
         <p:spPr>
           <a:xfrm>
-            <a:off x="5670000" y="5282550"/>
+            <a:off x="5670000" y="5166433"/>
             <a:ext cx="644716" cy="151200"/>
           </a:xfrm>
           <a:prstGeom prst="rect">
@@ -10551,7 +10560,7 @@
         </p:nvSpPr>
         <p:spPr>
           <a:xfrm>
-            <a:off x="6380640" y="5282550"/>
+            <a:off x="6380640" y="5166433"/>
             <a:ext cx="644716" cy="151200"/>
           </a:xfrm>
           <a:prstGeom prst="rect">
@@ -10588,7 +10597,7 @@
         </p:nvSpPr>
         <p:spPr>
           <a:xfrm>
-            <a:off x="604800" y="5577390"/>
+            <a:off x="604800" y="5443672"/>
             <a:ext cx="1776902" cy="151200"/>
           </a:xfrm>
           <a:prstGeom prst="rect">
@@ -10625,7 +10634,7 @@
         </p:nvSpPr>
         <p:spPr>
           <a:xfrm>
-            <a:off x="2404080" y="5577390"/>
+            <a:off x="2404080" y="5443672"/>
             <a:ext cx="833414" cy="151200"/>
           </a:xfrm>
           <a:prstGeom prst="rect">
@@ -10662,7 +10671,7 @@
         </p:nvSpPr>
         <p:spPr>
           <a:xfrm>
-            <a:off x="3296160" y="5577390"/>
+            <a:off x="3296160" y="5443672"/>
             <a:ext cx="503193" cy="151200"/>
           </a:xfrm>
           <a:prstGeom prst="rect">
@@ -10699,7 +10708,7 @@
         </p:nvSpPr>
         <p:spPr>
           <a:xfrm>
-            <a:off x="3870720" y="5577390"/>
+            <a:off x="3870720" y="5443672"/>
             <a:ext cx="723340" cy="151200"/>
           </a:xfrm>
           <a:prstGeom prst="rect">
@@ -10736,7 +10745,7 @@
         </p:nvSpPr>
         <p:spPr>
           <a:xfrm>
-            <a:off x="4656960" y="5577390"/>
+            <a:off x="4656960" y="5443672"/>
             <a:ext cx="959212" cy="151200"/>
           </a:xfrm>
           <a:prstGeom prst="rect">
@@ -10773,7 +10782,7 @@
         </p:nvSpPr>
         <p:spPr>
           <a:xfrm>
-            <a:off x="5670000" y="5577390"/>
+            <a:off x="5670000" y="5443672"/>
             <a:ext cx="644716" cy="151200"/>
           </a:xfrm>
           <a:prstGeom prst="rect">
@@ -10810,7 +10819,7 @@
         </p:nvSpPr>
         <p:spPr>
           <a:xfrm>
-            <a:off x="6380640" y="5577390"/>
+            <a:off x="6380640" y="5443672"/>
             <a:ext cx="644716" cy="151200"/>
           </a:xfrm>
           <a:prstGeom prst="rect">
@@ -10847,7 +10856,7 @@
         </p:nvSpPr>
         <p:spPr>
           <a:xfrm>
-            <a:off x="604800" y="5872230"/>
+            <a:off x="604800" y="5720911"/>
             <a:ext cx="1776902" cy="151200"/>
           </a:xfrm>
           <a:prstGeom prst="rect">
@@ -10884,7 +10893,7 @@
         </p:nvSpPr>
         <p:spPr>
           <a:xfrm>
-            <a:off x="2404080" y="5872230"/>
+            <a:off x="2404080" y="5720911"/>
             <a:ext cx="833414" cy="151200"/>
           </a:xfrm>
           <a:prstGeom prst="rect">
@@ -10921,7 +10930,7 @@
         </p:nvSpPr>
         <p:spPr>
           <a:xfrm>
-            <a:off x="3296160" y="5872230"/>
+            <a:off x="3296160" y="5720911"/>
             <a:ext cx="503193" cy="151200"/>
           </a:xfrm>
           <a:prstGeom prst="rect">
@@ -10958,7 +10967,7 @@
         </p:nvSpPr>
         <p:spPr>
           <a:xfrm>
-            <a:off x="3870720" y="5872230"/>
+            <a:off x="3870720" y="5720911"/>
             <a:ext cx="723340" cy="151200"/>
           </a:xfrm>
           <a:prstGeom prst="rect">
@@ -10995,7 +11004,7 @@
         </p:nvSpPr>
         <p:spPr>
           <a:xfrm>
-            <a:off x="4656960" y="5872230"/>
+            <a:off x="4656960" y="5720911"/>
             <a:ext cx="959212" cy="151200"/>
           </a:xfrm>
           <a:prstGeom prst="rect">
@@ -11032,7 +11041,7 @@
         </p:nvSpPr>
         <p:spPr>
           <a:xfrm>
-            <a:off x="5670000" y="5872230"/>
+            <a:off x="5670000" y="5720911"/>
             <a:ext cx="644716" cy="151200"/>
           </a:xfrm>
           <a:prstGeom prst="rect">
@@ -11069,7 +11078,7 @@
         </p:nvSpPr>
         <p:spPr>
           <a:xfrm>
-            <a:off x="6380640" y="5872230"/>
+            <a:off x="6380640" y="5720911"/>
             <a:ext cx="644716" cy="151200"/>
           </a:xfrm>
           <a:prstGeom prst="rect">
@@ -11106,7 +11115,7 @@
         </p:nvSpPr>
         <p:spPr>
           <a:xfrm>
-            <a:off x="604800" y="6167070"/>
+            <a:off x="604800" y="5998151"/>
             <a:ext cx="1776902" cy="151200"/>
           </a:xfrm>
           <a:prstGeom prst="rect">
@@ -11143,7 +11152,7 @@
         </p:nvSpPr>
         <p:spPr>
           <a:xfrm>
-            <a:off x="2404080" y="6167070"/>
+            <a:off x="2404080" y="5998151"/>
             <a:ext cx="833414" cy="151200"/>
           </a:xfrm>
           <a:prstGeom prst="rect">
@@ -11180,7 +11189,7 @@
         </p:nvSpPr>
         <p:spPr>
           <a:xfrm>
-            <a:off x="3296160" y="6167070"/>
+            <a:off x="3296160" y="5998151"/>
             <a:ext cx="503193" cy="151200"/>
           </a:xfrm>
           <a:prstGeom prst="rect">
@@ -11217,7 +11226,7 @@
         </p:nvSpPr>
         <p:spPr>
           <a:xfrm>
-            <a:off x="3870720" y="6167070"/>
+            <a:off x="3870720" y="5998151"/>
             <a:ext cx="723340" cy="151200"/>
           </a:xfrm>
           <a:prstGeom prst="rect">
@@ -11254,7 +11263,7 @@
         </p:nvSpPr>
         <p:spPr>
           <a:xfrm>
-            <a:off x="4656960" y="6167070"/>
+            <a:off x="4656960" y="5998151"/>
             <a:ext cx="959212" cy="151200"/>
           </a:xfrm>
           <a:prstGeom prst="rect">
@@ -11291,7 +11300,7 @@
         </p:nvSpPr>
         <p:spPr>
           <a:xfrm>
-            <a:off x="5670000" y="6167070"/>
+            <a:off x="5670000" y="5998151"/>
             <a:ext cx="644716" cy="151200"/>
           </a:xfrm>
           <a:prstGeom prst="rect">
@@ -11328,7 +11337,7 @@
         </p:nvSpPr>
         <p:spPr>
           <a:xfrm>
-            <a:off x="6380640" y="6167070"/>
+            <a:off x="6380640" y="5998151"/>
             <a:ext cx="644716" cy="151200"/>
           </a:xfrm>
           <a:prstGeom prst="rect">
@@ -11365,7 +11374,7 @@
         </p:nvSpPr>
         <p:spPr>
           <a:xfrm>
-            <a:off x="604800" y="6461910"/>
+            <a:off x="604800" y="6275390"/>
             <a:ext cx="1776902" cy="151200"/>
           </a:xfrm>
           <a:prstGeom prst="rect">
@@ -11402,7 +11411,7 @@
         </p:nvSpPr>
         <p:spPr>
           <a:xfrm>
-            <a:off x="2404080" y="6461910"/>
+            <a:off x="2404080" y="6275390"/>
             <a:ext cx="833414" cy="151200"/>
           </a:xfrm>
           <a:prstGeom prst="rect">
@@ -11439,7 +11448,7 @@
         </p:nvSpPr>
         <p:spPr>
           <a:xfrm>
-            <a:off x="3296160" y="6461910"/>
+            <a:off x="3296160" y="6275390"/>
             <a:ext cx="503193" cy="151200"/>
           </a:xfrm>
           <a:prstGeom prst="rect">
@@ -11476,7 +11485,7 @@
         </p:nvSpPr>
         <p:spPr>
           <a:xfrm>
-            <a:off x="3870720" y="6461910"/>
+            <a:off x="3870720" y="6275390"/>
             <a:ext cx="723340" cy="151200"/>
           </a:xfrm>
           <a:prstGeom prst="rect">
@@ -11513,7 +11522,7 @@
         </p:nvSpPr>
         <p:spPr>
           <a:xfrm>
-            <a:off x="4656960" y="6461910"/>
+            <a:off x="4656960" y="6275390"/>
             <a:ext cx="959212" cy="151200"/>
           </a:xfrm>
           <a:prstGeom prst="rect">
@@ -11550,7 +11559,7 @@
         </p:nvSpPr>
         <p:spPr>
           <a:xfrm>
-            <a:off x="5670000" y="6461910"/>
+            <a:off x="5670000" y="6275390"/>
             <a:ext cx="644716" cy="151200"/>
           </a:xfrm>
           <a:prstGeom prst="rect">
@@ -11587,7 +11596,7 @@
         </p:nvSpPr>
         <p:spPr>
           <a:xfrm>
-            <a:off x="6380640" y="6461910"/>
+            <a:off x="6380640" y="6275390"/>
             <a:ext cx="644716" cy="151200"/>
           </a:xfrm>
           <a:prstGeom prst="rect">
@@ -11624,7 +11633,7 @@
         </p:nvSpPr>
         <p:spPr>
           <a:xfrm>
-            <a:off x="604800" y="6756750"/>
+            <a:off x="604800" y="6552630"/>
             <a:ext cx="1776902" cy="151200"/>
           </a:xfrm>
           <a:prstGeom prst="rect">
@@ -11661,7 +11670,7 @@
         </p:nvSpPr>
         <p:spPr>
           <a:xfrm>
-            <a:off x="2404080" y="6756750"/>
+            <a:off x="2404080" y="6552630"/>
             <a:ext cx="833414" cy="151200"/>
           </a:xfrm>
           <a:prstGeom prst="rect">
@@ -11698,7 +11707,7 @@
         </p:nvSpPr>
         <p:spPr>
           <a:xfrm>
-            <a:off x="3296160" y="6756750"/>
+            <a:off x="3296160" y="6552630"/>
             <a:ext cx="503193" cy="151200"/>
           </a:xfrm>
           <a:prstGeom prst="rect">
@@ -11735,7 +11744,7 @@
         </p:nvSpPr>
         <p:spPr>
           <a:xfrm>
-            <a:off x="3870720" y="6756750"/>
+            <a:off x="3870720" y="6552630"/>
             <a:ext cx="723340" cy="151200"/>
           </a:xfrm>
           <a:prstGeom prst="rect">
@@ -11772,7 +11781,7 @@
         </p:nvSpPr>
         <p:spPr>
           <a:xfrm>
-            <a:off x="4656960" y="6756750"/>
+            <a:off x="4656960" y="6552630"/>
             <a:ext cx="959212" cy="151200"/>
           </a:xfrm>
           <a:prstGeom prst="rect">
@@ -11809,7 +11818,7 @@
         </p:nvSpPr>
         <p:spPr>
           <a:xfrm>
-            <a:off x="5670000" y="6756750"/>
+            <a:off x="5670000" y="6552630"/>
             <a:ext cx="644716" cy="151200"/>
           </a:xfrm>
           <a:prstGeom prst="rect">
@@ -11846,7 +11855,7 @@
         </p:nvSpPr>
         <p:spPr>
           <a:xfrm>
-            <a:off x="6380640" y="6756750"/>
+            <a:off x="6380640" y="6552630"/>
             <a:ext cx="644716" cy="151200"/>
           </a:xfrm>
           <a:prstGeom prst="rect">
@@ -11883,7 +11892,7 @@
         </p:nvSpPr>
         <p:spPr>
           <a:xfrm>
-            <a:off x="604800" y="7051590"/>
+            <a:off x="604800" y="6829869"/>
             <a:ext cx="1776902" cy="151200"/>
           </a:xfrm>
           <a:prstGeom prst="rect">
@@ -11920,7 +11929,7 @@
         </p:nvSpPr>
         <p:spPr>
           <a:xfrm>
-            <a:off x="2404080" y="7051590"/>
+            <a:off x="2404080" y="6829869"/>
             <a:ext cx="833414" cy="151200"/>
           </a:xfrm>
           <a:prstGeom prst="rect">
@@ -11957,7 +11966,7 @@
         </p:nvSpPr>
         <p:spPr>
           <a:xfrm>
-            <a:off x="3296160" y="7051590"/>
+            <a:off x="3296160" y="6829869"/>
             <a:ext cx="503193" cy="151200"/>
           </a:xfrm>
           <a:prstGeom prst="rect">
@@ -11994,7 +12003,7 @@
         </p:nvSpPr>
         <p:spPr>
           <a:xfrm>
-            <a:off x="3870720" y="7051590"/>
+            <a:off x="3870720" y="6829869"/>
             <a:ext cx="723340" cy="151200"/>
           </a:xfrm>
           <a:prstGeom prst="rect">
@@ -12031,7 +12040,7 @@
         </p:nvSpPr>
         <p:spPr>
           <a:xfrm>
-            <a:off x="4656960" y="7051590"/>
+            <a:off x="4656960" y="6829869"/>
             <a:ext cx="959212" cy="151200"/>
           </a:xfrm>
           <a:prstGeom prst="rect">
@@ -12068,7 +12077,7 @@
         </p:nvSpPr>
         <p:spPr>
           <a:xfrm>
-            <a:off x="5670000" y="7051590"/>
+            <a:off x="5670000" y="6829869"/>
             <a:ext cx="644716" cy="151200"/>
           </a:xfrm>
           <a:prstGeom prst="rect">
@@ -12105,7 +12114,7 @@
         </p:nvSpPr>
         <p:spPr>
           <a:xfrm>
-            <a:off x="6380640" y="7051590"/>
+            <a:off x="6380640" y="6829869"/>
             <a:ext cx="644716" cy="151200"/>
           </a:xfrm>
           <a:prstGeom prst="rect">
@@ -12142,7 +12151,7 @@
         </p:nvSpPr>
         <p:spPr>
           <a:xfrm>
-            <a:off x="604800" y="7288076"/>
+            <a:off x="604800" y="7065410"/>
             <a:ext cx="1708560" cy="298974"/>
           </a:xfrm>
           <a:prstGeom prst="rect">
@@ -12179,7 +12188,7 @@
         </p:nvSpPr>
         <p:spPr>
           <a:xfrm>
-            <a:off x="2404080" y="7361904"/>
+            <a:off x="2404080" y="7139238"/>
             <a:ext cx="833414" cy="151200"/>
           </a:xfrm>
           <a:prstGeom prst="rect">
@@ -12216,7 +12225,7 @@
         </p:nvSpPr>
         <p:spPr>
           <a:xfrm>
-            <a:off x="3296160" y="7361904"/>
+            <a:off x="3296160" y="7139238"/>
             <a:ext cx="503193" cy="151200"/>
           </a:xfrm>
           <a:prstGeom prst="rect">
@@ -12253,7 +12262,7 @@
         </p:nvSpPr>
         <p:spPr>
           <a:xfrm>
-            <a:off x="3870720" y="7361904"/>
+            <a:off x="3870720" y="7139238"/>
             <a:ext cx="723340" cy="151200"/>
           </a:xfrm>
           <a:prstGeom prst="rect">
@@ -12290,7 +12299,7 @@
         </p:nvSpPr>
         <p:spPr>
           <a:xfrm>
-            <a:off x="4656960" y="7361904"/>
+            <a:off x="4656960" y="7139238"/>
             <a:ext cx="959212" cy="151200"/>
           </a:xfrm>
           <a:prstGeom prst="rect">
@@ -12327,7 +12336,7 @@
         </p:nvSpPr>
         <p:spPr>
           <a:xfrm>
-            <a:off x="5670000" y="7361904"/>
+            <a:off x="5670000" y="7139238"/>
             <a:ext cx="644716" cy="151200"/>
           </a:xfrm>
           <a:prstGeom prst="rect">
@@ -12364,7 +12373,7 @@
         </p:nvSpPr>
         <p:spPr>
           <a:xfrm>
-            <a:off x="6380640" y="7361904"/>
+            <a:off x="6380640" y="7139238"/>
             <a:ext cx="644716" cy="151200"/>
           </a:xfrm>
           <a:prstGeom prst="rect">
@@ -12401,7 +12410,7 @@
         </p:nvSpPr>
         <p:spPr>
           <a:xfrm>
-            <a:off x="604800" y="7672218"/>
+            <a:off x="604800" y="7448726"/>
             <a:ext cx="1776902" cy="151200"/>
           </a:xfrm>
           <a:prstGeom prst="rect">
@@ -12438,7 +12447,7 @@
         </p:nvSpPr>
         <p:spPr>
           <a:xfrm>
-            <a:off x="2404080" y="7672218"/>
+            <a:off x="2404080" y="7448726"/>
             <a:ext cx="833414" cy="151200"/>
           </a:xfrm>
           <a:prstGeom prst="rect">
@@ -12475,7 +12484,7 @@
         </p:nvSpPr>
         <p:spPr>
           <a:xfrm>
-            <a:off x="3296160" y="7672218"/>
+            <a:off x="3296160" y="7448726"/>
             <a:ext cx="503193" cy="151200"/>
           </a:xfrm>
           <a:prstGeom prst="rect">
@@ -12512,7 +12521,7 @@
         </p:nvSpPr>
         <p:spPr>
           <a:xfrm>
-            <a:off x="3870720" y="7672218"/>
+            <a:off x="3870720" y="7448726"/>
             <a:ext cx="723340" cy="151200"/>
           </a:xfrm>
           <a:prstGeom prst="rect">
@@ -12549,7 +12558,7 @@
         </p:nvSpPr>
         <p:spPr>
           <a:xfrm>
-            <a:off x="4656960" y="7672218"/>
+            <a:off x="4656960" y="7448726"/>
             <a:ext cx="959212" cy="151200"/>
           </a:xfrm>
           <a:prstGeom prst="rect">
@@ -12586,7 +12595,7 @@
         </p:nvSpPr>
         <p:spPr>
           <a:xfrm>
-            <a:off x="5670000" y="7672218"/>
+            <a:off x="5670000" y="7448726"/>
             <a:ext cx="644716" cy="151200"/>
           </a:xfrm>
           <a:prstGeom prst="rect">
@@ -12623,7 +12632,7 @@
         </p:nvSpPr>
         <p:spPr>
           <a:xfrm>
-            <a:off x="6380640" y="7672218"/>
+            <a:off x="6380640" y="7448726"/>
             <a:ext cx="644716" cy="151200"/>
           </a:xfrm>
           <a:prstGeom prst="rect">
@@ -12660,7 +12669,7 @@
         </p:nvSpPr>
         <p:spPr>
           <a:xfrm>
-            <a:off x="604800" y="7908705"/>
+            <a:off x="604800" y="7684267"/>
             <a:ext cx="1708560" cy="298974"/>
           </a:xfrm>
           <a:prstGeom prst="rect">
@@ -12697,7 +12706,7 @@
         </p:nvSpPr>
         <p:spPr>
           <a:xfrm>
-            <a:off x="2404080" y="7982533"/>
+            <a:off x="2404080" y="7758095"/>
             <a:ext cx="833414" cy="151200"/>
           </a:xfrm>
           <a:prstGeom prst="rect">
@@ -12734,7 +12743,7 @@
         </p:nvSpPr>
         <p:spPr>
           <a:xfrm>
-            <a:off x="3296160" y="7982533"/>
+            <a:off x="3296160" y="7758095"/>
             <a:ext cx="503193" cy="151200"/>
           </a:xfrm>
           <a:prstGeom prst="rect">
@@ -12771,7 +12780,7 @@
         </p:nvSpPr>
         <p:spPr>
           <a:xfrm>
-            <a:off x="3870720" y="7982533"/>
+            <a:off x="3870720" y="7758095"/>
             <a:ext cx="723340" cy="151200"/>
           </a:xfrm>
           <a:prstGeom prst="rect">
@@ -12808,7 +12817,7 @@
         </p:nvSpPr>
         <p:spPr>
           <a:xfrm>
-            <a:off x="4656960" y="7982533"/>
+            <a:off x="4656960" y="7758095"/>
             <a:ext cx="959212" cy="151200"/>
           </a:xfrm>
           <a:prstGeom prst="rect">
@@ -12845,7 +12854,7 @@
         </p:nvSpPr>
         <p:spPr>
           <a:xfrm>
-            <a:off x="5670000" y="7982533"/>
+            <a:off x="5670000" y="7758095"/>
             <a:ext cx="644716" cy="151200"/>
           </a:xfrm>
           <a:prstGeom prst="rect">
@@ -12882,7 +12891,7 @@
         </p:nvSpPr>
         <p:spPr>
           <a:xfrm>
-            <a:off x="6380640" y="7982533"/>
+            <a:off x="6380640" y="7758095"/>
             <a:ext cx="644716" cy="151200"/>
           </a:xfrm>
           <a:prstGeom prst="rect">
@@ -12919,7 +12928,7 @@
         </p:nvSpPr>
         <p:spPr>
           <a:xfrm>
-            <a:off x="604800" y="8292847"/>
+            <a:off x="604800" y="8067583"/>
             <a:ext cx="1776902" cy="151200"/>
           </a:xfrm>
           <a:prstGeom prst="rect">
@@ -12956,7 +12965,7 @@
         </p:nvSpPr>
         <p:spPr>
           <a:xfrm>
-            <a:off x="2404080" y="8292847"/>
+            <a:off x="2404080" y="8067583"/>
             <a:ext cx="833414" cy="151200"/>
           </a:xfrm>
           <a:prstGeom prst="rect">
@@ -12993,7 +13002,7 @@
         </p:nvSpPr>
         <p:spPr>
           <a:xfrm>
-            <a:off x="3296160" y="8292847"/>
+            <a:off x="3296160" y="8067583"/>
             <a:ext cx="503193" cy="151200"/>
           </a:xfrm>
           <a:prstGeom prst="rect">
@@ -13030,7 +13039,7 @@
         </p:nvSpPr>
         <p:spPr>
           <a:xfrm>
-            <a:off x="3870720" y="8292847"/>
+            <a:off x="3870720" y="8067583"/>
             <a:ext cx="723340" cy="151200"/>
           </a:xfrm>
           <a:prstGeom prst="rect">
@@ -13067,7 +13076,7 @@
         </p:nvSpPr>
         <p:spPr>
           <a:xfrm>
-            <a:off x="4656960" y="8292847"/>
+            <a:off x="4656960" y="8067583"/>
             <a:ext cx="959212" cy="151200"/>
           </a:xfrm>
           <a:prstGeom prst="rect">
@@ -13104,7 +13113,7 @@
         </p:nvSpPr>
         <p:spPr>
           <a:xfrm>
-            <a:off x="5670000" y="8292847"/>
+            <a:off x="5670000" y="8067583"/>
             <a:ext cx="644716" cy="151200"/>
           </a:xfrm>
           <a:prstGeom prst="rect">
@@ -13141,7 +13150,7 @@
         </p:nvSpPr>
         <p:spPr>
           <a:xfrm>
-            <a:off x="6380640" y="8292847"/>
+            <a:off x="6380640" y="8067583"/>
             <a:ext cx="644716" cy="151200"/>
           </a:xfrm>
           <a:prstGeom prst="rect">
@@ -13178,7 +13187,7 @@
         </p:nvSpPr>
         <p:spPr>
           <a:xfrm>
-            <a:off x="604800" y="8587687"/>
+            <a:off x="604800" y="8344822"/>
             <a:ext cx="1776902" cy="151200"/>
           </a:xfrm>
           <a:prstGeom prst="rect">
@@ -13215,7 +13224,7 @@
         </p:nvSpPr>
         <p:spPr>
           <a:xfrm>
-            <a:off x="2404080" y="8587687"/>
+            <a:off x="2404080" y="8344822"/>
             <a:ext cx="833414" cy="151200"/>
           </a:xfrm>
           <a:prstGeom prst="rect">
@@ -13252,7 +13261,7 @@
         </p:nvSpPr>
         <p:spPr>
           <a:xfrm>
-            <a:off x="3296160" y="8587687"/>
+            <a:off x="3296160" y="8344822"/>
             <a:ext cx="503193" cy="151200"/>
           </a:xfrm>
           <a:prstGeom prst="rect">
@@ -13289,7 +13298,7 @@
         </p:nvSpPr>
         <p:spPr>
           <a:xfrm>
-            <a:off x="3870720" y="8587687"/>
+            <a:off x="3870720" y="8344822"/>
             <a:ext cx="723340" cy="151200"/>
           </a:xfrm>
           <a:prstGeom prst="rect">
@@ -13326,7 +13335,7 @@
         </p:nvSpPr>
         <p:spPr>
           <a:xfrm>
-            <a:off x="4656960" y="8587687"/>
+            <a:off x="4656960" y="8344822"/>
             <a:ext cx="959212" cy="151200"/>
           </a:xfrm>
           <a:prstGeom prst="rect">
@@ -13363,7 +13372,7 @@
         </p:nvSpPr>
         <p:spPr>
           <a:xfrm>
-            <a:off x="5670000" y="8587687"/>
+            <a:off x="5670000" y="8344822"/>
             <a:ext cx="644716" cy="151200"/>
           </a:xfrm>
           <a:prstGeom prst="rect">
@@ -13400,7 +13409,7 @@
         </p:nvSpPr>
         <p:spPr>
           <a:xfrm>
-            <a:off x="6380640" y="8587687"/>
+            <a:off x="6380640" y="8344822"/>
             <a:ext cx="644716" cy="151200"/>
           </a:xfrm>
           <a:prstGeom prst="rect">
@@ -13437,7 +13446,7 @@
         </p:nvSpPr>
         <p:spPr>
           <a:xfrm>
-            <a:off x="604800" y="8882527"/>
+            <a:off x="604800" y="8622061"/>
             <a:ext cx="1776902" cy="151200"/>
           </a:xfrm>
           <a:prstGeom prst="rect">
@@ -13474,7 +13483,7 @@
         </p:nvSpPr>
         <p:spPr>
           <a:xfrm>
-            <a:off x="2404080" y="8882527"/>
+            <a:off x="2404080" y="8622061"/>
             <a:ext cx="833414" cy="151200"/>
           </a:xfrm>
           <a:prstGeom prst="rect">
@@ -13511,7 +13520,7 @@
         </p:nvSpPr>
         <p:spPr>
           <a:xfrm>
-            <a:off x="3296160" y="8882527"/>
+            <a:off x="3296160" y="8622061"/>
             <a:ext cx="503193" cy="151200"/>
           </a:xfrm>
           <a:prstGeom prst="rect">
@@ -13548,7 +13557,7 @@
         </p:nvSpPr>
         <p:spPr>
           <a:xfrm>
-            <a:off x="3870720" y="8882527"/>
+            <a:off x="3870720" y="8622061"/>
             <a:ext cx="723340" cy="151200"/>
           </a:xfrm>
           <a:prstGeom prst="rect">
@@ -13585,7 +13594,7 @@
         </p:nvSpPr>
         <p:spPr>
           <a:xfrm>
-            <a:off x="4656960" y="8882527"/>
+            <a:off x="4656960" y="8622061"/>
             <a:ext cx="959212" cy="151200"/>
           </a:xfrm>
           <a:prstGeom prst="rect">
@@ -13622,7 +13631,7 @@
         </p:nvSpPr>
         <p:spPr>
           <a:xfrm>
-            <a:off x="5670000" y="8882527"/>
+            <a:off x="5670000" y="8622061"/>
             <a:ext cx="644716" cy="151200"/>
           </a:xfrm>
           <a:prstGeom prst="rect">
@@ -13659,7 +13668,7 @@
         </p:nvSpPr>
         <p:spPr>
           <a:xfrm>
-            <a:off x="6380640" y="8882527"/>
+            <a:off x="6380640" y="8622061"/>
             <a:ext cx="644716" cy="151200"/>
           </a:xfrm>
           <a:prstGeom prst="rect">
@@ -13696,7 +13705,7 @@
         </p:nvSpPr>
         <p:spPr>
           <a:xfrm>
-            <a:off x="604800" y="9177367"/>
+            <a:off x="604800" y="8899301"/>
             <a:ext cx="1776902" cy="151200"/>
           </a:xfrm>
           <a:prstGeom prst="rect">
@@ -13733,7 +13742,7 @@
         </p:nvSpPr>
         <p:spPr>
           <a:xfrm>
-            <a:off x="2404080" y="9177367"/>
+            <a:off x="2404080" y="8899301"/>
             <a:ext cx="833414" cy="151200"/>
           </a:xfrm>
           <a:prstGeom prst="rect">
@@ -13770,7 +13779,7 @@
         </p:nvSpPr>
         <p:spPr>
           <a:xfrm>
-            <a:off x="3296160" y="9177367"/>
+            <a:off x="3296160" y="8899301"/>
             <a:ext cx="503193" cy="151200"/>
           </a:xfrm>
           <a:prstGeom prst="rect">
@@ -13807,7 +13816,7 @@
         </p:nvSpPr>
         <p:spPr>
           <a:xfrm>
-            <a:off x="3870720" y="9177367"/>
+            <a:off x="3870720" y="8899301"/>
             <a:ext cx="723340" cy="151200"/>
           </a:xfrm>
           <a:prstGeom prst="rect">
@@ -13844,7 +13853,7 @@
         </p:nvSpPr>
         <p:spPr>
           <a:xfrm>
-            <a:off x="4656960" y="9177367"/>
+            <a:off x="4656960" y="8899301"/>
             <a:ext cx="959212" cy="151200"/>
           </a:xfrm>
           <a:prstGeom prst="rect">
@@ -13881,7 +13890,7 @@
         </p:nvSpPr>
         <p:spPr>
           <a:xfrm>
-            <a:off x="5670000" y="9177367"/>
+            <a:off x="5670000" y="8899301"/>
             <a:ext cx="644716" cy="151200"/>
           </a:xfrm>
           <a:prstGeom prst="rect">
@@ -13918,7 +13927,7 @@
         </p:nvSpPr>
         <p:spPr>
           <a:xfrm>
-            <a:off x="6380640" y="9177367"/>
+            <a:off x="6380640" y="8899301"/>
             <a:ext cx="644716" cy="151200"/>
           </a:xfrm>
           <a:prstGeom prst="rect">
@@ -13955,7 +13964,7 @@
         </p:nvSpPr>
         <p:spPr>
           <a:xfrm>
-            <a:off x="604800" y="9472207"/>
+            <a:off x="604800" y="9177131"/>
             <a:ext cx="1776902" cy="151200"/>
           </a:xfrm>
           <a:prstGeom prst="rect">
@@ -13992,7 +14001,7 @@
         </p:nvSpPr>
         <p:spPr>
           <a:xfrm>
-            <a:off x="2404080" y="9472207"/>
+            <a:off x="2404080" y="9177131"/>
             <a:ext cx="833414" cy="151200"/>
           </a:xfrm>
           <a:prstGeom prst="rect">
@@ -14029,7 +14038,7 @@
         </p:nvSpPr>
         <p:spPr>
           <a:xfrm>
-            <a:off x="3296160" y="9472207"/>
+            <a:off x="3296160" y="9177131"/>
             <a:ext cx="503193" cy="151200"/>
           </a:xfrm>
           <a:prstGeom prst="rect">
@@ -14066,7 +14075,7 @@
         </p:nvSpPr>
         <p:spPr>
           <a:xfrm>
-            <a:off x="3870720" y="9472207"/>
+            <a:off x="3870720" y="9177131"/>
             <a:ext cx="723340" cy="151200"/>
           </a:xfrm>
           <a:prstGeom prst="rect">
@@ -14103,7 +14112,7 @@
         </p:nvSpPr>
         <p:spPr>
           <a:xfrm>
-            <a:off x="4656960" y="9472207"/>
+            <a:off x="4656960" y="9177131"/>
             <a:ext cx="959212" cy="151200"/>
           </a:xfrm>
           <a:prstGeom prst="rect">
@@ -14140,7 +14149,7 @@
         </p:nvSpPr>
         <p:spPr>
           <a:xfrm>
-            <a:off x="5670000" y="9472207"/>
+            <a:off x="5670000" y="9177131"/>
             <a:ext cx="644716" cy="151200"/>
           </a:xfrm>
           <a:prstGeom prst="rect">
@@ -14177,7 +14186,7 @@
         </p:nvSpPr>
         <p:spPr>
           <a:xfrm>
-            <a:off x="6380640" y="9472207"/>
+            <a:off x="6380640" y="9177131"/>
             <a:ext cx="644716" cy="151200"/>
           </a:xfrm>
           <a:prstGeom prst="rect">

</xml_diff>